<commit_message>
feat: make EvalCall six-step workflow fully executable
</commit_message>
<xml_diff>
--- a/docs/EvalCall答辩稿-可信评测基础设施-20260712.pptx
+++ b/docs/EvalCall答辩稿-可信评测基础设施-20260712.pptx
@@ -2,20 +2,20 @@
 <file path=ppt/presentation.xml><?xml version="1.0" encoding="utf-8"?>
 <p:presentation xmlns:p="http://schemas.openxmlformats.org/presentationml/2006/main">
   <p:sldMasterIdLst>
-    <p:sldMasterId xmlns:r="http://schemas.openxmlformats.org/officeDocument/2006/relationships" id="2147483648" r:id="R58d5e0417b584858"/>
+    <p:sldMasterId xmlns:r="http://schemas.openxmlformats.org/officeDocument/2006/relationships" id="2147483648" r:id="R7f16af8dc49d4d75"/>
   </p:sldMasterIdLst>
   <p:notesMasterIdLst>
-    <p:notesMasterId xmlns:r="http://schemas.openxmlformats.org/officeDocument/2006/relationships" r:id="R999508801583447b"/>
+    <p:notesMasterId xmlns:r="http://schemas.openxmlformats.org/officeDocument/2006/relationships" r:id="Rf6f0e75c1dff49dd"/>
   </p:notesMasterIdLst>
   <p:sldIdLst>
-    <p:sldId xmlns:r="http://schemas.openxmlformats.org/officeDocument/2006/relationships" id="256" r:id="R84358fbe7b3c4b9d"/>
-    <p:sldId xmlns:r="http://schemas.openxmlformats.org/officeDocument/2006/relationships" id="257" r:id="Re787a98381f64c64"/>
-    <p:sldId xmlns:r="http://schemas.openxmlformats.org/officeDocument/2006/relationships" id="258" r:id="Rcb0f98ccf0f44ab2"/>
-    <p:sldId xmlns:r="http://schemas.openxmlformats.org/officeDocument/2006/relationships" id="259" r:id="Raa0a8872cdeb48a4"/>
-    <p:sldId xmlns:r="http://schemas.openxmlformats.org/officeDocument/2006/relationships" id="260" r:id="Re15b54bb4a1f42b2"/>
-    <p:sldId xmlns:r="http://schemas.openxmlformats.org/officeDocument/2006/relationships" id="261" r:id="Rf090b476d11d4c8b"/>
-    <p:sldId xmlns:r="http://schemas.openxmlformats.org/officeDocument/2006/relationships" id="262" r:id="Rb440ff3bd4be41f8"/>
-    <p:sldId xmlns:r="http://schemas.openxmlformats.org/officeDocument/2006/relationships" id="263" r:id="R4b9bb9e352e14afa"/>
+    <p:sldId xmlns:r="http://schemas.openxmlformats.org/officeDocument/2006/relationships" id="256" r:id="R8e624a8bb5104c91"/>
+    <p:sldId xmlns:r="http://schemas.openxmlformats.org/officeDocument/2006/relationships" id="257" r:id="Rbec874605eee4c66"/>
+    <p:sldId xmlns:r="http://schemas.openxmlformats.org/officeDocument/2006/relationships" id="258" r:id="Rf257eba08975429f"/>
+    <p:sldId xmlns:r="http://schemas.openxmlformats.org/officeDocument/2006/relationships" id="259" r:id="Rdc731b378fd24998"/>
+    <p:sldId xmlns:r="http://schemas.openxmlformats.org/officeDocument/2006/relationships" id="260" r:id="Re83108b3fc3f4903"/>
+    <p:sldId xmlns:r="http://schemas.openxmlformats.org/officeDocument/2006/relationships" id="261" r:id="Ra17ba3d7788243fe"/>
+    <p:sldId xmlns:r="http://schemas.openxmlformats.org/officeDocument/2006/relationships" id="262" r:id="R4b29076745f148e0"/>
+    <p:sldId xmlns:r="http://schemas.openxmlformats.org/officeDocument/2006/relationships" id="263" r:id="R6919a1353d79415e"/>
   </p:sldIdLst>
   <p:sldSz cx="12192000" cy="6858000"/>
   <p:notesSz cx="6858000" cy="9144000"/>
@@ -1070,7 +1070,7 @@
   </p:cSld>
   <p:clrMap bg1="lt1" tx1="dk1" bg2="lt2" tx2="dk2" accent1="accent1" accent2="accent2" accent3="accent3" accent4="accent4" accent5="accent5" accent6="accent6" hlink="hlink" folHlink="folHlink"/>
   <p:sldLayoutIdLst>
-    <p:sldLayoutId xmlns:r="http://schemas.openxmlformats.org/officeDocument/2006/relationships" id="2147483649" r:id="R35db1573e4fb47fe"/>
+    <p:sldLayoutId xmlns:r="http://schemas.openxmlformats.org/officeDocument/2006/relationships" id="2147483649" r:id="Rd917bd2367894fca"/>
   </p:sldLayoutIdLst>
   <p:txStyles>
     <p:titleStyle>
@@ -1867,6 +1867,7 @@
           <a:lstStyle xmlns:a="http://schemas.openxmlformats.org/drawingml/2006/main"/>
           <a:p xmlns:a="http://schemas.openxmlformats.org/drawingml/2006/main">
             <a:pPr algn="l">
+              <a:buNone/>
               <a:defRPr sz="1350" b="1">
                 <a:solidFill>
                   <a:srgbClr val="667085"/>
@@ -1925,6 +1926,7 @@
           <a:lstStyle xmlns:a="http://schemas.openxmlformats.org/drawingml/2006/main"/>
           <a:p xmlns:a="http://schemas.openxmlformats.org/drawingml/2006/main">
             <a:pPr algn="l">
+              <a:buNone/>
               <a:defRPr sz="5250" b="1">
                 <a:solidFill>
                   <a:srgbClr val="111827"/>
@@ -1948,6 +1950,7 @@
           </a:p>
           <a:p xmlns:a="http://schemas.openxmlformats.org/drawingml/2006/main">
             <a:pPr algn="l">
+              <a:buNone/>
               <a:defRPr sz="5250" b="1">
                 <a:solidFill>
                   <a:srgbClr val="111827"/>
@@ -2006,6 +2009,7 @@
           <a:lstStyle xmlns:a="http://schemas.openxmlformats.org/drawingml/2006/main"/>
           <a:p xmlns:a="http://schemas.openxmlformats.org/drawingml/2006/main">
             <a:pPr algn="l">
+              <a:buNone/>
               <a:defRPr sz="2175" b="0">
                 <a:solidFill>
                   <a:srgbClr val="111827"/>
@@ -2064,6 +2068,7 @@
           <a:lstStyle xmlns:a="http://schemas.openxmlformats.org/drawingml/2006/main"/>
           <a:p xmlns:a="http://schemas.openxmlformats.org/drawingml/2006/main">
             <a:pPr algn="l">
+              <a:buNone/>
               <a:defRPr sz="1350" b="0">
                 <a:solidFill>
                   <a:srgbClr val="667085"/>
@@ -2082,7 +2087,7 @@
                 <a:ea typeface="PingFang SC"/>
                 <a:cs typeface="PingFang SC"/>
               </a:rPr>
-              <a:t>32-case / 165 真值校准  ·  真实生产 SOP 三票评测  ·  每个数字可追溯</a:t>
+              <a:t>六步真实链路  ·  四类可选样例  ·  32-case / 165 真值校准  ·  每个数字可追溯</a:t>
             </a:r>
           </a:p>
         </p:txBody>
@@ -2122,6 +2127,7 @@
           <a:lstStyle xmlns:a="http://schemas.openxmlformats.org/drawingml/2006/main"/>
           <a:p xmlns:a="http://schemas.openxmlformats.org/drawingml/2006/main">
             <a:pPr algn="ctr">
+              <a:buNone/>
               <a:defRPr sz="4800" b="1">
                 <a:solidFill>
                   <a:srgbClr val="111827"/>
@@ -2180,6 +2186,7 @@
           <a:lstStyle xmlns:a="http://schemas.openxmlformats.org/drawingml/2006/main"/>
           <a:p xmlns:a="http://schemas.openxmlformats.org/drawingml/2006/main">
             <a:pPr algn="r">
+              <a:buNone/>
               <a:defRPr sz="1050" b="0">
                 <a:solidFill>
                   <a:srgbClr val="111827"/>
@@ -2267,6 +2274,7 @@
           <a:lstStyle xmlns:a="http://schemas.openxmlformats.org/drawingml/2006/main"/>
           <a:p xmlns:a="http://schemas.openxmlformats.org/drawingml/2006/main">
             <a:pPr algn="l">
+              <a:buNone/>
               <a:defRPr sz="1200" b="1">
                 <a:solidFill>
                   <a:srgbClr val="667085"/>
@@ -2325,6 +2333,7 @@
           <a:lstStyle xmlns:a="http://schemas.openxmlformats.org/drawingml/2006/main"/>
           <a:p xmlns:a="http://schemas.openxmlformats.org/drawingml/2006/main">
             <a:pPr algn="l">
+              <a:buNone/>
               <a:defRPr sz="3300" b="1">
                 <a:solidFill>
                   <a:srgbClr val="111827"/>
@@ -2414,6 +2423,7 @@
           <a:lstStyle xmlns:a="http://schemas.openxmlformats.org/drawingml/2006/main"/>
           <a:p xmlns:a="http://schemas.openxmlformats.org/drawingml/2006/main">
             <a:pPr algn="r">
+              <a:buNone/>
               <a:defRPr sz="1050" b="0">
                 <a:solidFill>
                   <a:srgbClr val="667085"/>
@@ -2472,6 +2482,7 @@
           <a:lstStyle xmlns:a="http://schemas.openxmlformats.org/drawingml/2006/main"/>
           <a:p xmlns:a="http://schemas.openxmlformats.org/drawingml/2006/main">
             <a:pPr algn="l">
+              <a:buNone/>
               <a:defRPr sz="4050" b="1">
                 <a:solidFill>
                   <a:srgbClr val="111827"/>
@@ -2495,6 +2506,7 @@
           </a:p>
           <a:p xmlns:a="http://schemas.openxmlformats.org/drawingml/2006/main">
             <a:pPr algn="l">
+              <a:buNone/>
               <a:defRPr sz="4050" b="1">
                 <a:solidFill>
                   <a:srgbClr val="111827"/>
@@ -2553,6 +2565,7 @@
           <a:lstStyle xmlns:a="http://schemas.openxmlformats.org/drawingml/2006/main"/>
           <a:p xmlns:a="http://schemas.openxmlformats.org/drawingml/2006/main">
             <a:pPr algn="l">
+              <a:buNone/>
               <a:defRPr sz="1800" b="0">
                 <a:solidFill>
                   <a:srgbClr val="667085"/>
@@ -2642,6 +2655,7 @@
           <a:lstStyle xmlns:a="http://schemas.openxmlformats.org/drawingml/2006/main"/>
           <a:p xmlns:a="http://schemas.openxmlformats.org/drawingml/2006/main">
             <a:pPr algn="l">
+              <a:buNone/>
               <a:defRPr sz="2100" b="1">
                 <a:solidFill>
                   <a:srgbClr val="667085"/>
@@ -2700,6 +2714,7 @@
           <a:lstStyle xmlns:a="http://schemas.openxmlformats.org/drawingml/2006/main"/>
           <a:p xmlns:a="http://schemas.openxmlformats.org/drawingml/2006/main">
             <a:pPr algn="l">
+              <a:buNone/>
               <a:defRPr sz="1875" b="1">
                 <a:solidFill>
                   <a:srgbClr val="111827"/>
@@ -2758,6 +2773,7 @@
           <a:lstStyle xmlns:a="http://schemas.openxmlformats.org/drawingml/2006/main"/>
           <a:p xmlns:a="http://schemas.openxmlformats.org/drawingml/2006/main">
             <a:pPr algn="l">
+              <a:buNone/>
               <a:defRPr sz="1350" b="0">
                 <a:solidFill>
                   <a:srgbClr val="667085"/>
@@ -2847,6 +2863,7 @@
           <a:lstStyle xmlns:a="http://schemas.openxmlformats.org/drawingml/2006/main"/>
           <a:p xmlns:a="http://schemas.openxmlformats.org/drawingml/2006/main">
             <a:pPr algn="l">
+              <a:buNone/>
               <a:defRPr sz="2100" b="1">
                 <a:solidFill>
                   <a:srgbClr val="8A6400"/>
@@ -2905,6 +2922,7 @@
           <a:lstStyle xmlns:a="http://schemas.openxmlformats.org/drawingml/2006/main"/>
           <a:p xmlns:a="http://schemas.openxmlformats.org/drawingml/2006/main">
             <a:pPr algn="l">
+              <a:buNone/>
               <a:defRPr sz="1875" b="1">
                 <a:solidFill>
                   <a:srgbClr val="111827"/>
@@ -2963,6 +2981,7 @@
           <a:lstStyle xmlns:a="http://schemas.openxmlformats.org/drawingml/2006/main"/>
           <a:p xmlns:a="http://schemas.openxmlformats.org/drawingml/2006/main">
             <a:pPr algn="l">
+              <a:buNone/>
               <a:defRPr sz="1350" b="0">
                 <a:solidFill>
                   <a:srgbClr val="667085"/>
@@ -3052,6 +3071,7 @@
           <a:lstStyle xmlns:a="http://schemas.openxmlformats.org/drawingml/2006/main"/>
           <a:p xmlns:a="http://schemas.openxmlformats.org/drawingml/2006/main">
             <a:pPr algn="l">
+              <a:buNone/>
               <a:defRPr sz="2100" b="1">
                 <a:solidFill>
                   <a:srgbClr val="667085"/>
@@ -3110,6 +3130,7 @@
           <a:lstStyle xmlns:a="http://schemas.openxmlformats.org/drawingml/2006/main"/>
           <a:p xmlns:a="http://schemas.openxmlformats.org/drawingml/2006/main">
             <a:pPr algn="l">
+              <a:buNone/>
               <a:defRPr sz="1875" b="1">
                 <a:solidFill>
                   <a:srgbClr val="111827"/>
@@ -3168,6 +3189,7 @@
           <a:lstStyle xmlns:a="http://schemas.openxmlformats.org/drawingml/2006/main"/>
           <a:p xmlns:a="http://schemas.openxmlformats.org/drawingml/2006/main">
             <a:pPr algn="l">
+              <a:buNone/>
               <a:defRPr sz="1350" b="0">
                 <a:solidFill>
                   <a:srgbClr val="667085"/>
@@ -3226,6 +3248,7 @@
           <a:lstStyle xmlns:a="http://schemas.openxmlformats.org/drawingml/2006/main"/>
           <a:p xmlns:a="http://schemas.openxmlformats.org/drawingml/2006/main">
             <a:pPr algn="l">
+              <a:buNone/>
               <a:defRPr sz="900" b="0">
                 <a:solidFill>
                   <a:srgbClr val="667085"/>
@@ -3313,6 +3336,7 @@
           <a:lstStyle xmlns:a="http://schemas.openxmlformats.org/drawingml/2006/main"/>
           <a:p xmlns:a="http://schemas.openxmlformats.org/drawingml/2006/main">
             <a:pPr algn="l">
+              <a:buNone/>
               <a:defRPr sz="1200" b="1">
                 <a:solidFill>
                   <a:srgbClr val="667085"/>
@@ -3371,6 +3395,7 @@
           <a:lstStyle xmlns:a="http://schemas.openxmlformats.org/drawingml/2006/main"/>
           <a:p xmlns:a="http://schemas.openxmlformats.org/drawingml/2006/main">
             <a:pPr algn="l">
+              <a:buNone/>
               <a:defRPr sz="3300" b="1">
                 <a:solidFill>
                   <a:srgbClr val="111827"/>
@@ -3389,7 +3414,7 @@
                 <a:ea typeface="PingFang SC"/>
                 <a:cs typeface="PingFang SC"/>
               </a:rPr>
-              <a:t>四步工作台，把评测收口为业务决策</a:t>
+              <a:t>六步工作台，每一步都有可验收产物</a:t>
             </a:r>
           </a:p>
         </p:txBody>
@@ -3460,6 +3485,7 @@
           <a:lstStyle xmlns:a="http://schemas.openxmlformats.org/drawingml/2006/main"/>
           <a:p xmlns:a="http://schemas.openxmlformats.org/drawingml/2006/main">
             <a:pPr algn="r">
+              <a:buNone/>
               <a:defRPr sz="1050" b="0">
                 <a:solidFill>
                   <a:srgbClr val="667085"/>
@@ -3499,8 +3525,8 @@
         </p:nvSpPr>
         <p:spPr>
           <a:xfrm xmlns:a="http://schemas.openxmlformats.org/drawingml/2006/main">
-            <a:off x="1409700" y="3305175"/>
-            <a:ext cx="8991600" cy="38100"/>
+            <a:off x="1981200" y="2428875"/>
+            <a:ext cx="7600950" cy="38100"/>
           </a:xfrm>
           <a:prstGeom xmlns:a="http://schemas.openxmlformats.org/drawingml/2006/main" prst="rect">
             <a:avLst/>
@@ -3530,7 +3556,7 @@
         </p:nvSpPr>
         <p:spPr>
           <a:xfrm xmlns:a="http://schemas.openxmlformats.org/drawingml/2006/main">
-            <a:off x="1219200" y="3009900"/>
+            <a:off x="1666875" y="2133600"/>
             <a:ext cx="628650" cy="628650"/>
           </a:xfrm>
           <a:prstGeom xmlns:a="http://schemas.openxmlformats.org/drawingml/2006/main" prst="roundRect">
@@ -3563,7 +3589,7 @@
         </p:nvSpPr>
         <p:spPr>
           <a:xfrm xmlns:a="http://schemas.openxmlformats.org/drawingml/2006/main">
-            <a:off x="1219200" y="3067050"/>
+            <a:off x="1666875" y="2190750"/>
             <a:ext cx="628650" cy="495300"/>
           </a:xfrm>
           <a:prstGeom xmlns:a="http://schemas.openxmlformats.org/drawingml/2006/main" prst="rect">
@@ -3582,6 +3608,7 @@
           <a:lstStyle xmlns:a="http://schemas.openxmlformats.org/drawingml/2006/main"/>
           <a:p xmlns:a="http://schemas.openxmlformats.org/drawingml/2006/main">
             <a:pPr algn="ctr">
+              <a:buNone/>
               <a:defRPr sz="2025" b="1">
                 <a:solidFill>
                   <a:srgbClr val="FFFFFF"/>
@@ -3621,8 +3648,8 @@
         </p:nvSpPr>
         <p:spPr>
           <a:xfrm xmlns:a="http://schemas.openxmlformats.org/drawingml/2006/main">
-            <a:off x="666750" y="3943350"/>
-            <a:ext cx="1733550" cy="361950"/>
+            <a:off x="838200" y="2895600"/>
+            <a:ext cx="2286000" cy="361950"/>
           </a:xfrm>
           <a:prstGeom xmlns:a="http://schemas.openxmlformats.org/drawingml/2006/main" prst="rect">
             <a:avLst/>
@@ -3640,6 +3667,7 @@
           <a:lstStyle xmlns:a="http://schemas.openxmlformats.org/drawingml/2006/main"/>
           <a:p xmlns:a="http://schemas.openxmlformats.org/drawingml/2006/main">
             <a:pPr algn="ctr">
+              <a:buNone/>
               <a:defRPr sz="1950" b="1">
                 <a:solidFill>
                   <a:srgbClr val="111827"/>
@@ -3658,7 +3686,7 @@
                 <a:ea typeface="PingFang SC"/>
                 <a:cs typeface="PingFang SC"/>
               </a:rPr>
-              <a:t>选择 SOP</a:t>
+              <a:t>上传材料</a:t>
             </a:r>
           </a:p>
         </p:txBody>
@@ -3679,8 +3707,8 @@
         </p:nvSpPr>
         <p:spPr>
           <a:xfrm xmlns:a="http://schemas.openxmlformats.org/drawingml/2006/main">
-            <a:off x="514350" y="4438650"/>
-            <a:ext cx="2038350" cy="514350"/>
+            <a:off x="742950" y="3314700"/>
+            <a:ext cx="2476500" cy="400050"/>
           </a:xfrm>
           <a:prstGeom xmlns:a="http://schemas.openxmlformats.org/drawingml/2006/main" prst="rect">
             <a:avLst/>
@@ -3698,6 +3726,7 @@
           <a:lstStyle xmlns:a="http://schemas.openxmlformats.org/drawingml/2006/main"/>
           <a:p xmlns:a="http://schemas.openxmlformats.org/drawingml/2006/main">
             <a:pPr algn="ctr">
+              <a:buNone/>
               <a:defRPr sz="1350" b="0">
                 <a:solidFill>
                   <a:srgbClr val="667085"/>
@@ -3716,7 +3745,7 @@
                 <a:ea typeface="PingFang SC"/>
                 <a:cs typeface="PingFang SC"/>
               </a:rPr>
-              <a:t>定义该遵循什么</a:t>
+              <a:t>SOP + 对话记录</a:t>
             </a:r>
           </a:p>
         </p:txBody>
@@ -3737,7 +3766,7 @@
         </p:nvSpPr>
         <p:spPr>
           <a:xfrm xmlns:a="http://schemas.openxmlformats.org/drawingml/2006/main">
-            <a:off x="4076700" y="3009900"/>
+            <a:off x="5467350" y="2133600"/>
             <a:ext cx="628650" cy="628650"/>
           </a:xfrm>
           <a:prstGeom xmlns:a="http://schemas.openxmlformats.org/drawingml/2006/main" prst="roundRect">
@@ -3770,7 +3799,7 @@
         </p:nvSpPr>
         <p:spPr>
           <a:xfrm xmlns:a="http://schemas.openxmlformats.org/drawingml/2006/main">
-            <a:off x="4076700" y="3067050"/>
+            <a:off x="5467350" y="2190750"/>
             <a:ext cx="628650" cy="495300"/>
           </a:xfrm>
           <a:prstGeom xmlns:a="http://schemas.openxmlformats.org/drawingml/2006/main" prst="rect">
@@ -3789,6 +3818,7 @@
           <a:lstStyle xmlns:a="http://schemas.openxmlformats.org/drawingml/2006/main"/>
           <a:p xmlns:a="http://schemas.openxmlformats.org/drawingml/2006/main">
             <a:pPr algn="ctr">
+              <a:buNone/>
               <a:defRPr sz="2025" b="1">
                 <a:solidFill>
                   <a:srgbClr val="FFFFFF"/>
@@ -3828,8 +3858,8 @@
         </p:nvSpPr>
         <p:spPr>
           <a:xfrm xmlns:a="http://schemas.openxmlformats.org/drawingml/2006/main">
-            <a:off x="3524250" y="3943350"/>
-            <a:ext cx="1733550" cy="361950"/>
+            <a:off x="4638675" y="2895600"/>
+            <a:ext cx="2286000" cy="361950"/>
           </a:xfrm>
           <a:prstGeom xmlns:a="http://schemas.openxmlformats.org/drawingml/2006/main" prst="rect">
             <a:avLst/>
@@ -3847,6 +3877,7 @@
           <a:lstStyle xmlns:a="http://schemas.openxmlformats.org/drawingml/2006/main"/>
           <a:p xmlns:a="http://schemas.openxmlformats.org/drawingml/2006/main">
             <a:pPr algn="ctr">
+              <a:buNone/>
               <a:defRPr sz="1950" b="1">
                 <a:solidFill>
                   <a:srgbClr val="111827"/>
@@ -3865,7 +3896,7 @@
                 <a:ea typeface="PingFang SC"/>
                 <a:cs typeface="PingFang SC"/>
               </a:rPr>
-              <a:t>导入对话</a:t>
+              <a:t>生成标准</a:t>
             </a:r>
           </a:p>
         </p:txBody>
@@ -3886,8 +3917,8 @@
         </p:nvSpPr>
         <p:spPr>
           <a:xfrm xmlns:a="http://schemas.openxmlformats.org/drawingml/2006/main">
-            <a:off x="3371850" y="4438650"/>
-            <a:ext cx="2038350" cy="514350"/>
+            <a:off x="4543425" y="3314700"/>
+            <a:ext cx="2476500" cy="400050"/>
           </a:xfrm>
           <a:prstGeom xmlns:a="http://schemas.openxmlformats.org/drawingml/2006/main" prst="rect">
             <a:avLst/>
@@ -3905,6 +3936,7 @@
           <a:lstStyle xmlns:a="http://schemas.openxmlformats.org/drawingml/2006/main"/>
           <a:p xmlns:a="http://schemas.openxmlformats.org/drawingml/2006/main">
             <a:pPr algn="ctr">
+              <a:buNone/>
               <a:defRPr sz="1350" b="0">
                 <a:solidFill>
                   <a:srgbClr val="667085"/>
@@ -3923,7 +3955,7 @@
                 <a:ea typeface="PingFang SC"/>
                 <a:cs typeface="PingFang SC"/>
               </a:rPr>
-              <a:t>真实 / 脱敏 / ASR</a:t>
+              <a:t>L0 红线 + L1 业务</a:t>
             </a:r>
           </a:p>
         </p:txBody>
@@ -3944,7 +3976,7 @@
         </p:nvSpPr>
         <p:spPr>
           <a:xfrm xmlns:a="http://schemas.openxmlformats.org/drawingml/2006/main">
-            <a:off x="6934200" y="3009900"/>
+            <a:off x="9267825" y="2133600"/>
             <a:ext cx="628650" cy="628650"/>
           </a:xfrm>
           <a:prstGeom xmlns:a="http://schemas.openxmlformats.org/drawingml/2006/main" prst="roundRect">
@@ -3977,7 +4009,7 @@
         </p:nvSpPr>
         <p:spPr>
           <a:xfrm xmlns:a="http://schemas.openxmlformats.org/drawingml/2006/main">
-            <a:off x="6934200" y="3067050"/>
+            <a:off x="9267825" y="2190750"/>
             <a:ext cx="628650" cy="495300"/>
           </a:xfrm>
           <a:prstGeom xmlns:a="http://schemas.openxmlformats.org/drawingml/2006/main" prst="rect">
@@ -3996,6 +4028,7 @@
           <a:lstStyle xmlns:a="http://schemas.openxmlformats.org/drawingml/2006/main"/>
           <a:p xmlns:a="http://schemas.openxmlformats.org/drawingml/2006/main">
             <a:pPr algn="ctr">
+              <a:buNone/>
               <a:defRPr sz="2025" b="1">
                 <a:solidFill>
                   <a:srgbClr val="FFFFFF"/>
@@ -4035,8 +4068,8 @@
         </p:nvSpPr>
         <p:spPr>
           <a:xfrm xmlns:a="http://schemas.openxmlformats.org/drawingml/2006/main">
-            <a:off x="6381750" y="3943350"/>
-            <a:ext cx="1733550" cy="361950"/>
+            <a:off x="8439150" y="2895600"/>
+            <a:ext cx="2286000" cy="361950"/>
           </a:xfrm>
           <a:prstGeom xmlns:a="http://schemas.openxmlformats.org/drawingml/2006/main" prst="rect">
             <a:avLst/>
@@ -4054,6 +4087,7 @@
           <a:lstStyle xmlns:a="http://schemas.openxmlformats.org/drawingml/2006/main"/>
           <a:p xmlns:a="http://schemas.openxmlformats.org/drawingml/2006/main">
             <a:pPr algn="ctr">
+              <a:buNone/>
               <a:defRPr sz="1950" b="1">
                 <a:solidFill>
                   <a:srgbClr val="111827"/>
@@ -4072,7 +4106,7 @@
                 <a:ea typeface="PingFang SC"/>
                 <a:cs typeface="PingFang SC"/>
               </a:rPr>
-              <a:t>确认检查尺</a:t>
+              <a:t>逐通检查</a:t>
             </a:r>
           </a:p>
         </p:txBody>
@@ -4093,8 +4127,8 @@
         </p:nvSpPr>
         <p:spPr>
           <a:xfrm xmlns:a="http://schemas.openxmlformats.org/drawingml/2006/main">
-            <a:off x="6229350" y="4438650"/>
-            <a:ext cx="2038350" cy="514350"/>
+            <a:off x="8343900" y="3314700"/>
+            <a:ext cx="2476500" cy="400050"/>
           </a:xfrm>
           <a:prstGeom xmlns:a="http://schemas.openxmlformats.org/drawingml/2006/main" prst="rect">
             <a:avLst/>
@@ -4112,6 +4146,7 @@
           <a:lstStyle xmlns:a="http://schemas.openxmlformats.org/drawingml/2006/main"/>
           <a:p xmlns:a="http://schemas.openxmlformats.org/drawingml/2006/main">
             <a:pPr algn="ctr">
+              <a:buNone/>
               <a:defRPr sz="1350" b="0">
                 <a:solidFill>
                   <a:srgbClr val="667085"/>
@@ -4130,7 +4165,7 @@
                 <a:ea typeface="PingFang SC"/>
                 <a:cs typeface="PingFang SC"/>
               </a:rPr>
-              <a:t>L0 红线 + L1 业务</a:t>
+              <a:t>逐项判定 + 原始证据</a:t>
             </a:r>
           </a:p>
         </p:txBody>
@@ -4151,7 +4186,7 @@
         </p:nvSpPr>
         <p:spPr>
           <a:xfrm xmlns:a="http://schemas.openxmlformats.org/drawingml/2006/main">
-            <a:off x="9791700" y="3009900"/>
+            <a:off x="1666875" y="4095750"/>
             <a:ext cx="628650" cy="628650"/>
           </a:xfrm>
           <a:prstGeom xmlns:a="http://schemas.openxmlformats.org/drawingml/2006/main" prst="roundRect">
@@ -4184,7 +4219,7 @@
         </p:nvSpPr>
         <p:spPr>
           <a:xfrm xmlns:a="http://schemas.openxmlformats.org/drawingml/2006/main">
-            <a:off x="9791700" y="3067050"/>
+            <a:off x="1666875" y="4152900"/>
             <a:ext cx="628650" cy="495300"/>
           </a:xfrm>
           <a:prstGeom xmlns:a="http://schemas.openxmlformats.org/drawingml/2006/main" prst="rect">
@@ -4203,6 +4238,7 @@
           <a:lstStyle xmlns:a="http://schemas.openxmlformats.org/drawingml/2006/main"/>
           <a:p xmlns:a="http://schemas.openxmlformats.org/drawingml/2006/main">
             <a:pPr algn="ctr">
+              <a:buNone/>
               <a:defRPr sz="2025" b="1">
                 <a:solidFill>
                   <a:srgbClr val="111827"/>
@@ -4242,8 +4278,8 @@
         </p:nvSpPr>
         <p:spPr>
           <a:xfrm xmlns:a="http://schemas.openxmlformats.org/drawingml/2006/main">
-            <a:off x="9239250" y="3943350"/>
-            <a:ext cx="1733550" cy="361950"/>
+            <a:off x="838200" y="4857750"/>
+            <a:ext cx="2286000" cy="361950"/>
           </a:xfrm>
           <a:prstGeom xmlns:a="http://schemas.openxmlformats.org/drawingml/2006/main" prst="rect">
             <a:avLst/>
@@ -4261,6 +4297,7 @@
           <a:lstStyle xmlns:a="http://schemas.openxmlformats.org/drawingml/2006/main"/>
           <a:p xmlns:a="http://schemas.openxmlformats.org/drawingml/2006/main">
             <a:pPr algn="ctr">
+              <a:buNone/>
               <a:defRPr sz="1950" b="1">
                 <a:solidFill>
                   <a:srgbClr val="111827"/>
@@ -4279,7 +4316,7 @@
                 <a:ea typeface="PingFang SC"/>
                 <a:cs typeface="PingFang SC"/>
               </a:rPr>
-              <a:t>评测与决策</a:t>
+              <a:t>统计决策</a:t>
             </a:r>
           </a:p>
         </p:txBody>
@@ -4300,8 +4337,8 @@
         </p:nvSpPr>
         <p:spPr>
           <a:xfrm xmlns:a="http://schemas.openxmlformats.org/drawingml/2006/main">
-            <a:off x="9086850" y="4438650"/>
-            <a:ext cx="2038350" cy="514350"/>
+            <a:off x="742950" y="5276850"/>
+            <a:ext cx="2476500" cy="400050"/>
           </a:xfrm>
           <a:prstGeom xmlns:a="http://schemas.openxmlformats.org/drawingml/2006/main" prst="rect">
             <a:avLst/>
@@ -4319,6 +4356,7 @@
           <a:lstStyle xmlns:a="http://schemas.openxmlformats.org/drawingml/2006/main"/>
           <a:p xmlns:a="http://schemas.openxmlformats.org/drawingml/2006/main">
             <a:pPr algn="ctr">
+              <a:buNone/>
               <a:defRPr sz="1350" b="0">
                 <a:solidFill>
                   <a:srgbClr val="667085"/>
@@ -4337,7 +4375,7 @@
                 <a:ea typeface="PingFang SC"/>
                 <a:cs typeface="PingFang SC"/>
               </a:rPr>
-              <a:t>可上线 / 打回 / 无法判定</a:t>
+              <a:t>门禁 + 问题比例</a:t>
             </a:r>
           </a:p>
         </p:txBody>
@@ -4358,25 +4396,26 @@
         </p:nvSpPr>
         <p:spPr>
           <a:xfrm xmlns:a="http://schemas.openxmlformats.org/drawingml/2006/main">
-            <a:off x="1562100" y="5486400"/>
-            <a:ext cx="9067800" cy="400050"/>
-          </a:xfrm>
-          <a:prstGeom xmlns:a="http://schemas.openxmlformats.org/drawingml/2006/main" prst="rect">
-            <a:avLst/>
-          </a:prstGeom>
-          <a:noFill xmlns:a="http://schemas.openxmlformats.org/drawingml/2006/main"/>
-          <a:ln xmlns:a="http://schemas.openxmlformats.org/drawingml/2006/main" w="0">
-            <a:noFill/>
-            <a:prstDash val="solid"/>
-          </a:ln>
-        </p:spPr>
-        <p:txBody>
-          <a:bodyPr xmlns:a="http://schemas.openxmlformats.org/drawingml/2006/main" anchor="t">
-            <a:normAutofit fontScale="100000"/>
+            <a:off x="1143000" y="5810250"/>
+            <a:ext cx="9906000" cy="323850"/>
+          </a:xfrm>
+          <a:prstGeom xmlns:a="http://schemas.openxmlformats.org/drawingml/2006/main" prst="rect">
+            <a:avLst/>
+          </a:prstGeom>
+          <a:noFill xmlns:a="http://schemas.openxmlformats.org/drawingml/2006/main"/>
+          <a:ln xmlns:a="http://schemas.openxmlformats.org/drawingml/2006/main" w="0">
+            <a:noFill/>
+            <a:prstDash val="solid"/>
+          </a:ln>
+        </p:spPr>
+        <p:txBody>
+          <a:bodyPr xmlns:a="http://schemas.openxmlformats.org/drawingml/2006/main" anchor="t">
+            <a:normAutofit fontScale="84722"/>
           </a:bodyPr>
           <a:lstStyle xmlns:a="http://schemas.openxmlformats.org/drawingml/2006/main"/>
           <a:p xmlns:a="http://schemas.openxmlformats.org/drawingml/2006/main">
             <a:pPr algn="ctr">
+              <a:buNone/>
               <a:defRPr sz="1800" b="1">
                 <a:solidFill>
                   <a:srgbClr val="111827"/>
@@ -4395,7 +4434,7 @@
                 <a:ea typeface="PingFang SC"/>
                 <a:cs typeface="PingFang SC"/>
               </a:rPr>
-              <a:t>输出不止一个分数：门禁、P0、履约、证据、根因 owner、复核队列一次给齐。</a:t>
+              <a:t>每步保留输入、输出与产物路径；历史结果与本地实时运行明确区分。</a:t>
             </a:r>
           </a:p>
         </p:txBody>
@@ -4435,6 +4474,7 @@
           <a:lstStyle xmlns:a="http://schemas.openxmlformats.org/drawingml/2006/main"/>
           <a:p xmlns:a="http://schemas.openxmlformats.org/drawingml/2006/main">
             <a:pPr algn="l">
+              <a:buNone/>
               <a:defRPr sz="900" b="0">
                 <a:solidFill>
                   <a:srgbClr val="667085"/>
@@ -4454,6 +4494,403 @@
                 <a:cs typeface="PingFang SC"/>
               </a:rPr>
               <a:t>产品入口：site-deploy/app.html · 本地服务：python -m evalcall demo</a:t>
+            </a:r>
+          </a:p>
+        </p:txBody>
+      </p:sp>
+      <p:sp>
+        <p:nvSpPr>
+          <p:cNvPr id="24" name="flow-line-row-2">
+            <a:extLst xmlns:a="http://schemas.openxmlformats.org/drawingml/2006/main">
+              <a:ext uri="{FF2B5EF4-FFF2-40B4-BE49-F238E27FC236}">
+                <a16:creationId xmlns:a16="http://schemas.microsoft.com/office/drawing/2014/main" id="{9FF7EABC-BEE2-4BDE-96F0-2075FF5DBD3E}"/>
+              </a:ext>
+            </a:extLst>
+          </p:cNvPr>
+          <p:cNvSpPr>
+            <a:spLocks xmlns:a="http://schemas.openxmlformats.org/drawingml/2006/main" noGrp="1"/>
+          </p:cNvSpPr>
+          <p:nvPr/>
+        </p:nvSpPr>
+        <p:spPr>
+          <a:xfrm xmlns:a="http://schemas.openxmlformats.org/drawingml/2006/main">
+            <a:off x="1981200" y="4391025"/>
+            <a:ext cx="7600950" cy="38100"/>
+          </a:xfrm>
+          <a:prstGeom xmlns:a="http://schemas.openxmlformats.org/drawingml/2006/main" prst="rect">
+            <a:avLst/>
+          </a:prstGeom>
+          <a:solidFill xmlns:a="http://schemas.openxmlformats.org/drawingml/2006/main">
+            <a:srgbClr val="CBD5E1"/>
+          </a:solidFill>
+          <a:ln xmlns:a="http://schemas.openxmlformats.org/drawingml/2006/main" w="0">
+            <a:noFill/>
+            <a:prstDash val="solid"/>
+          </a:ln>
+        </p:spPr>
+      </p:sp>
+      <p:sp>
+        <p:nvSpPr>
+          <p:cNvPr id="25" name="step-dot-5">
+            <a:extLst xmlns:a="http://schemas.openxmlformats.org/drawingml/2006/main">
+              <a:ext uri="{FF2B5EF4-FFF2-40B4-BE49-F238E27FC236}">
+                <a16:creationId xmlns:a16="http://schemas.microsoft.com/office/drawing/2014/main" id="{F9E6E76D-3B64-4136-83D1-EDAB2A48275D}"/>
+              </a:ext>
+            </a:extLst>
+          </p:cNvPr>
+          <p:cNvSpPr>
+            <a:spLocks xmlns:a="http://schemas.openxmlformats.org/drawingml/2006/main" noGrp="1"/>
+          </p:cNvSpPr>
+          <p:nvPr/>
+        </p:nvSpPr>
+        <p:spPr>
+          <a:xfrm xmlns:a="http://schemas.openxmlformats.org/drawingml/2006/main">
+            <a:off x="5467350" y="4095750"/>
+            <a:ext cx="628650" cy="628650"/>
+          </a:xfrm>
+          <a:prstGeom xmlns:a="http://schemas.openxmlformats.org/drawingml/2006/main" prst="ellipse">
+            <a:avLst/>
+          </a:prstGeom>
+          <a:solidFill xmlns:a="http://schemas.openxmlformats.org/drawingml/2006/main">
+            <a:srgbClr val="111827"/>
+          </a:solidFill>
+          <a:ln xmlns:a="http://schemas.openxmlformats.org/drawingml/2006/main" w="9525">
+            <a:solidFill>
+              <a:srgbClr val="111827"/>
+            </a:solidFill>
+            <a:prstDash val="solid"/>
+          </a:ln>
+        </p:spPr>
+      </p:sp>
+      <p:sp>
+        <p:nvSpPr>
+          <p:cNvPr id="26" name="step-n-5">
+            <a:extLst xmlns:a="http://schemas.openxmlformats.org/drawingml/2006/main">
+              <a:ext uri="{FF2B5EF4-FFF2-40B4-BE49-F238E27FC236}">
+                <a16:creationId xmlns:a16="http://schemas.microsoft.com/office/drawing/2014/main" id="{A480B850-43FF-4E9C-8036-9539608A5708}"/>
+              </a:ext>
+            </a:extLst>
+          </p:cNvPr>
+          <p:cNvSpPr>
+            <a:spLocks xmlns:a="http://schemas.openxmlformats.org/drawingml/2006/main" noGrp="1"/>
+          </p:cNvSpPr>
+          <p:nvPr/>
+        </p:nvSpPr>
+        <p:spPr>
+          <a:xfrm xmlns:a="http://schemas.openxmlformats.org/drawingml/2006/main">
+            <a:off x="5467350" y="4152900"/>
+            <a:ext cx="628650" cy="495300"/>
+          </a:xfrm>
+          <a:prstGeom xmlns:a="http://schemas.openxmlformats.org/drawingml/2006/main" prst="rect">
+            <a:avLst/>
+          </a:prstGeom>
+          <a:noFill xmlns:a="http://schemas.openxmlformats.org/drawingml/2006/main"/>
+          <a:ln xmlns:a="http://schemas.openxmlformats.org/drawingml/2006/main" w="0">
+            <a:noFill/>
+            <a:prstDash val="solid"/>
+          </a:ln>
+        </p:spPr>
+        <p:txBody>
+          <a:bodyPr xmlns:a="http://schemas.openxmlformats.org/drawingml/2006/main" anchor="ctr"/>
+          <a:lstStyle xmlns:a="http://schemas.openxmlformats.org/drawingml/2006/main"/>
+          <a:p xmlns:a="http://schemas.openxmlformats.org/drawingml/2006/main">
+            <a:pPr algn="ctr">
+              <a:defRPr sz="1350" b="1">
+                <a:solidFill>
+                  <a:srgbClr val="FFFFFF"/>
+                </a:solidFill>
+              </a:defRPr>
+            </a:pPr>
+            <a:r>
+              <a:rPr sz="1350" b="1">
+                <a:solidFill>
+                  <a:srgbClr val="FFFFFF"/>
+                </a:solidFill>
+              </a:rPr>
+              <a:t>5</a:t>
+            </a:r>
+          </a:p>
+        </p:txBody>
+      </p:sp>
+      <p:sp>
+        <p:nvSpPr>
+          <p:cNvPr id="27" name="step-title-5">
+            <a:extLst xmlns:a="http://schemas.openxmlformats.org/drawingml/2006/main">
+              <a:ext uri="{FF2B5EF4-FFF2-40B4-BE49-F238E27FC236}">
+                <a16:creationId xmlns:a16="http://schemas.microsoft.com/office/drawing/2014/main" id="{4879BEE7-933F-434D-9BC8-9F5EF41EB9B3}"/>
+              </a:ext>
+            </a:extLst>
+          </p:cNvPr>
+          <p:cNvSpPr>
+            <a:spLocks xmlns:a="http://schemas.openxmlformats.org/drawingml/2006/main" noGrp="1"/>
+          </p:cNvSpPr>
+          <p:nvPr/>
+        </p:nvSpPr>
+        <p:spPr>
+          <a:xfrm xmlns:a="http://schemas.openxmlformats.org/drawingml/2006/main">
+            <a:off x="4638675" y="4857750"/>
+            <a:ext cx="2286000" cy="361950"/>
+          </a:xfrm>
+          <a:prstGeom xmlns:a="http://schemas.openxmlformats.org/drawingml/2006/main" prst="rect">
+            <a:avLst/>
+          </a:prstGeom>
+          <a:noFill xmlns:a="http://schemas.openxmlformats.org/drawingml/2006/main"/>
+          <a:ln xmlns:a="http://schemas.openxmlformats.org/drawingml/2006/main" w="0">
+            <a:noFill/>
+            <a:prstDash val="solid"/>
+          </a:ln>
+        </p:spPr>
+        <p:txBody>
+          <a:bodyPr xmlns:a="http://schemas.openxmlformats.org/drawingml/2006/main"/>
+          <a:lstStyle xmlns:a="http://schemas.openxmlformats.org/drawingml/2006/main"/>
+          <a:p xmlns:a="http://schemas.openxmlformats.org/drawingml/2006/main">
+            <a:pPr algn="ctr">
+              <a:defRPr sz="1500" b="1">
+                <a:solidFill>
+                  <a:srgbClr val="111827"/>
+                </a:solidFill>
+              </a:defRPr>
+            </a:pPr>
+            <a:r>
+              <a:rPr sz="1500" b="1">
+                <a:solidFill>
+                  <a:srgbClr val="111827"/>
+                </a:solidFill>
+              </a:rPr>
+              <a:t>根因归因</a:t>
+            </a:r>
+          </a:p>
+        </p:txBody>
+      </p:sp>
+      <p:sp>
+        <p:nvSpPr>
+          <p:cNvPr id="28" name="step-body-5">
+            <a:extLst xmlns:a="http://schemas.openxmlformats.org/drawingml/2006/main">
+              <a:ext uri="{FF2B5EF4-FFF2-40B4-BE49-F238E27FC236}">
+                <a16:creationId xmlns:a16="http://schemas.microsoft.com/office/drawing/2014/main" id="{6A2887F8-74C4-4104-8D6A-242A585D4AA6}"/>
+              </a:ext>
+            </a:extLst>
+          </p:cNvPr>
+          <p:cNvSpPr>
+            <a:spLocks xmlns:a="http://schemas.openxmlformats.org/drawingml/2006/main" noGrp="1"/>
+          </p:cNvSpPr>
+          <p:nvPr/>
+        </p:nvSpPr>
+        <p:spPr>
+          <a:xfrm xmlns:a="http://schemas.openxmlformats.org/drawingml/2006/main">
+            <a:off x="4543425" y="5276850"/>
+            <a:ext cx="2476500" cy="400050"/>
+          </a:xfrm>
+          <a:prstGeom xmlns:a="http://schemas.openxmlformats.org/drawingml/2006/main" prst="rect">
+            <a:avLst/>
+          </a:prstGeom>
+          <a:noFill xmlns:a="http://schemas.openxmlformats.org/drawingml/2006/main"/>
+          <a:ln xmlns:a="http://schemas.openxmlformats.org/drawingml/2006/main" w="0">
+            <a:noFill/>
+            <a:prstDash val="solid"/>
+          </a:ln>
+        </p:spPr>
+        <p:txBody>
+          <a:bodyPr xmlns:a="http://schemas.openxmlformats.org/drawingml/2006/main"/>
+          <a:lstStyle xmlns:a="http://schemas.openxmlformats.org/drawingml/2006/main"/>
+          <a:p xmlns:a="http://schemas.openxmlformats.org/drawingml/2006/main">
+            <a:pPr algn="ctr">
+              <a:defRPr sz="900">
+                <a:solidFill>
+                  <a:srgbClr val="64748B"/>
+                </a:solidFill>
+              </a:defRPr>
+            </a:pPr>
+            <a:r>
+              <a:rPr sz="900">
+                <a:solidFill>
+                  <a:srgbClr val="64748B"/>
+                </a:solidFill>
+              </a:rPr>
+              <a:t>原因 + 证据 + 负责人</a:t>
+            </a:r>
+          </a:p>
+        </p:txBody>
+      </p:sp>
+      <p:sp>
+        <p:nvSpPr>
+          <p:cNvPr id="29" name="step-dot-6">
+            <a:extLst xmlns:a="http://schemas.openxmlformats.org/drawingml/2006/main">
+              <a:ext uri="{FF2B5EF4-FFF2-40B4-BE49-F238E27FC236}">
+                <a16:creationId xmlns:a16="http://schemas.microsoft.com/office/drawing/2014/main" id="{23E73DBE-3366-4643-901F-4A27567DF65A}"/>
+              </a:ext>
+            </a:extLst>
+          </p:cNvPr>
+          <p:cNvSpPr>
+            <a:spLocks xmlns:a="http://schemas.openxmlformats.org/drawingml/2006/main" noGrp="1"/>
+          </p:cNvSpPr>
+          <p:nvPr/>
+        </p:nvSpPr>
+        <p:spPr>
+          <a:xfrm xmlns:a="http://schemas.openxmlformats.org/drawingml/2006/main">
+            <a:off x="9267825" y="4095750"/>
+            <a:ext cx="628650" cy="628650"/>
+          </a:xfrm>
+          <a:prstGeom xmlns:a="http://schemas.openxmlformats.org/drawingml/2006/main" prst="ellipse">
+            <a:avLst/>
+          </a:prstGeom>
+          <a:solidFill xmlns:a="http://schemas.openxmlformats.org/drawingml/2006/main">
+            <a:srgbClr val="FFCC00"/>
+          </a:solidFill>
+          <a:ln xmlns:a="http://schemas.openxmlformats.org/drawingml/2006/main" w="9525">
+            <a:solidFill>
+              <a:srgbClr val="FFCC00"/>
+            </a:solidFill>
+            <a:prstDash val="solid"/>
+          </a:ln>
+        </p:spPr>
+      </p:sp>
+      <p:sp>
+        <p:nvSpPr>
+          <p:cNvPr id="30" name="step-n-6">
+            <a:extLst xmlns:a="http://schemas.openxmlformats.org/drawingml/2006/main">
+              <a:ext uri="{FF2B5EF4-FFF2-40B4-BE49-F238E27FC236}">
+                <a16:creationId xmlns:a16="http://schemas.microsoft.com/office/drawing/2014/main" id="{0AF895B3-0C7D-4F4A-AD53-77115BEBA63A}"/>
+              </a:ext>
+            </a:extLst>
+          </p:cNvPr>
+          <p:cNvSpPr>
+            <a:spLocks xmlns:a="http://schemas.openxmlformats.org/drawingml/2006/main" noGrp="1"/>
+          </p:cNvSpPr>
+          <p:nvPr/>
+        </p:nvSpPr>
+        <p:spPr>
+          <a:xfrm xmlns:a="http://schemas.openxmlformats.org/drawingml/2006/main">
+            <a:off x="9267825" y="4152900"/>
+            <a:ext cx="628650" cy="495300"/>
+          </a:xfrm>
+          <a:prstGeom xmlns:a="http://schemas.openxmlformats.org/drawingml/2006/main" prst="rect">
+            <a:avLst/>
+          </a:prstGeom>
+          <a:noFill xmlns:a="http://schemas.openxmlformats.org/drawingml/2006/main"/>
+          <a:ln xmlns:a="http://schemas.openxmlformats.org/drawingml/2006/main" w="0">
+            <a:noFill/>
+            <a:prstDash val="solid"/>
+          </a:ln>
+        </p:spPr>
+        <p:txBody>
+          <a:bodyPr xmlns:a="http://schemas.openxmlformats.org/drawingml/2006/main" anchor="ctr"/>
+          <a:lstStyle xmlns:a="http://schemas.openxmlformats.org/drawingml/2006/main"/>
+          <a:p xmlns:a="http://schemas.openxmlformats.org/drawingml/2006/main">
+            <a:pPr algn="ctr">
+              <a:defRPr sz="1350" b="1">
+                <a:solidFill>
+                  <a:srgbClr val="111827"/>
+                </a:solidFill>
+              </a:defRPr>
+            </a:pPr>
+            <a:r>
+              <a:rPr sz="1350" b="1">
+                <a:solidFill>
+                  <a:srgbClr val="111827"/>
+                </a:solidFill>
+              </a:rPr>
+              <a:t>6</a:t>
+            </a:r>
+          </a:p>
+        </p:txBody>
+      </p:sp>
+      <p:sp>
+        <p:nvSpPr>
+          <p:cNvPr id="31" name="step-title-6">
+            <a:extLst xmlns:a="http://schemas.openxmlformats.org/drawingml/2006/main">
+              <a:ext uri="{FF2B5EF4-FFF2-40B4-BE49-F238E27FC236}">
+                <a16:creationId xmlns:a16="http://schemas.microsoft.com/office/drawing/2014/main" id="{52A093D1-21A9-4D21-AA78-5E4C7BFEB39C}"/>
+              </a:ext>
+            </a:extLst>
+          </p:cNvPr>
+          <p:cNvSpPr>
+            <a:spLocks xmlns:a="http://schemas.openxmlformats.org/drawingml/2006/main" noGrp="1"/>
+          </p:cNvSpPr>
+          <p:nvPr/>
+        </p:nvSpPr>
+        <p:spPr>
+          <a:xfrm xmlns:a="http://schemas.openxmlformats.org/drawingml/2006/main">
+            <a:off x="8439150" y="4857750"/>
+            <a:ext cx="2286000" cy="361950"/>
+          </a:xfrm>
+          <a:prstGeom xmlns:a="http://schemas.openxmlformats.org/drawingml/2006/main" prst="rect">
+            <a:avLst/>
+          </a:prstGeom>
+          <a:noFill xmlns:a="http://schemas.openxmlformats.org/drawingml/2006/main"/>
+          <a:ln xmlns:a="http://schemas.openxmlformats.org/drawingml/2006/main" w="0">
+            <a:noFill/>
+            <a:prstDash val="solid"/>
+          </a:ln>
+        </p:spPr>
+        <p:txBody>
+          <a:bodyPr xmlns:a="http://schemas.openxmlformats.org/drawingml/2006/main"/>
+          <a:lstStyle xmlns:a="http://schemas.openxmlformats.org/drawingml/2006/main"/>
+          <a:p xmlns:a="http://schemas.openxmlformats.org/drawingml/2006/main">
+            <a:pPr algn="ctr">
+              <a:defRPr sz="1500" b="1">
+                <a:solidFill>
+                  <a:srgbClr val="111827"/>
+                </a:solidFill>
+              </a:defRPr>
+            </a:pPr>
+            <a:r>
+              <a:rPr sz="1500" b="1">
+                <a:solidFill>
+                  <a:srgbClr val="111827"/>
+                </a:solidFill>
+              </a:rPr>
+              <a:t>修复回归</a:t>
+            </a:r>
+          </a:p>
+        </p:txBody>
+      </p:sp>
+      <p:sp>
+        <p:nvSpPr>
+          <p:cNvPr id="32" name="step-body-6">
+            <a:extLst xmlns:a="http://schemas.openxmlformats.org/drawingml/2006/main">
+              <a:ext uri="{FF2B5EF4-FFF2-40B4-BE49-F238E27FC236}">
+                <a16:creationId xmlns:a16="http://schemas.microsoft.com/office/drawing/2014/main" id="{230A79F8-88BC-4067-BD59-AED39F7BAC2D}"/>
+              </a:ext>
+            </a:extLst>
+          </p:cNvPr>
+          <p:cNvSpPr>
+            <a:spLocks xmlns:a="http://schemas.openxmlformats.org/drawingml/2006/main" noGrp="1"/>
+          </p:cNvSpPr>
+          <p:nvPr/>
+        </p:nvSpPr>
+        <p:spPr>
+          <a:xfrm xmlns:a="http://schemas.openxmlformats.org/drawingml/2006/main">
+            <a:off x="8343900" y="5276850"/>
+            <a:ext cx="2476500" cy="400050"/>
+          </a:xfrm>
+          <a:prstGeom xmlns:a="http://schemas.openxmlformats.org/drawingml/2006/main" prst="rect">
+            <a:avLst/>
+          </a:prstGeom>
+          <a:noFill xmlns:a="http://schemas.openxmlformats.org/drawingml/2006/main"/>
+          <a:ln xmlns:a="http://schemas.openxmlformats.org/drawingml/2006/main" w="0">
+            <a:noFill/>
+            <a:prstDash val="solid"/>
+          </a:ln>
+        </p:spPr>
+        <p:txBody>
+          <a:bodyPr xmlns:a="http://schemas.openxmlformats.org/drawingml/2006/main"/>
+          <a:lstStyle xmlns:a="http://schemas.openxmlformats.org/drawingml/2006/main"/>
+          <a:p xmlns:a="http://schemas.openxmlformats.org/drawingml/2006/main">
+            <a:pPr algn="ctr">
+              <a:defRPr sz="900">
+                <a:solidFill>
+                  <a:srgbClr val="64748B"/>
+                </a:solidFill>
+              </a:defRPr>
+            </a:pPr>
+            <a:r>
+              <a:rPr sz="900">
+                <a:solidFill>
+                  <a:srgbClr val="64748B"/>
+                </a:solidFill>
+              </a:rPr>
+              <a:t>修复草案 + 同尺回归</a:t>
             </a:r>
           </a:p>
         </p:txBody>
@@ -4522,6 +4959,7 @@
           <a:lstStyle xmlns:a="http://schemas.openxmlformats.org/drawingml/2006/main"/>
           <a:p xmlns:a="http://schemas.openxmlformats.org/drawingml/2006/main">
             <a:pPr algn="l">
+              <a:buNone/>
               <a:defRPr sz="1200" b="1">
                 <a:solidFill>
                   <a:srgbClr val="667085"/>
@@ -4580,6 +5018,7 @@
           <a:lstStyle xmlns:a="http://schemas.openxmlformats.org/drawingml/2006/main"/>
           <a:p xmlns:a="http://schemas.openxmlformats.org/drawingml/2006/main">
             <a:pPr algn="l">
+              <a:buNone/>
               <a:defRPr sz="3300" b="1">
                 <a:solidFill>
                   <a:srgbClr val="111827"/>
@@ -4669,6 +5108,7 @@
           <a:lstStyle xmlns:a="http://schemas.openxmlformats.org/drawingml/2006/main"/>
           <a:p xmlns:a="http://schemas.openxmlformats.org/drawingml/2006/main">
             <a:pPr algn="r">
+              <a:buNone/>
               <a:defRPr sz="1050" b="0">
                 <a:solidFill>
                   <a:srgbClr val="667085"/>
@@ -4789,6 +5229,7 @@
           <a:lstStyle xmlns:a="http://schemas.openxmlformats.org/drawingml/2006/main"/>
           <a:p xmlns:a="http://schemas.openxmlformats.org/drawingml/2006/main">
             <a:pPr algn="l">
+              <a:buNone/>
               <a:defRPr sz="1350" b="1">
                 <a:solidFill>
                   <a:srgbClr val="3D8DFF"/>
@@ -4847,6 +5288,7 @@
           <a:lstStyle xmlns:a="http://schemas.openxmlformats.org/drawingml/2006/main"/>
           <a:p xmlns:a="http://schemas.openxmlformats.org/drawingml/2006/main">
             <a:pPr algn="l">
+              <a:buNone/>
               <a:defRPr sz="3000" b="1">
                 <a:solidFill>
                   <a:srgbClr val="111827"/>
@@ -4905,6 +5347,7 @@
           <a:lstStyle xmlns:a="http://schemas.openxmlformats.org/drawingml/2006/main"/>
           <a:p xmlns:a="http://schemas.openxmlformats.org/drawingml/2006/main">
             <a:pPr algn="l">
+              <a:buNone/>
               <a:defRPr sz="1800" b="1">
                 <a:solidFill>
                   <a:srgbClr val="111827"/>
@@ -4963,6 +5406,7 @@
           <a:lstStyle xmlns:a="http://schemas.openxmlformats.org/drawingml/2006/main"/>
           <a:p xmlns:a="http://schemas.openxmlformats.org/drawingml/2006/main">
             <a:pPr algn="l">
+              <a:buNone/>
               <a:defRPr sz="1500" b="0">
                 <a:solidFill>
                   <a:srgbClr val="667085"/>
@@ -4986,6 +5430,7 @@
           </a:p>
           <a:p xmlns:a="http://schemas.openxmlformats.org/drawingml/2006/main">
             <a:pPr algn="l">
+              <a:buNone/>
               <a:defRPr sz="1500" b="0">
                 <a:solidFill>
                   <a:srgbClr val="667085"/>
@@ -5044,6 +5489,7 @@
           <a:lstStyle xmlns:a="http://schemas.openxmlformats.org/drawingml/2006/main"/>
           <a:p xmlns:a="http://schemas.openxmlformats.org/drawingml/2006/main">
             <a:pPr algn="l">
+              <a:buNone/>
               <a:defRPr sz="1350" b="1">
                 <a:solidFill>
                   <a:srgbClr val="087F5B"/>
@@ -5102,6 +5548,7 @@
           <a:lstStyle xmlns:a="http://schemas.openxmlformats.org/drawingml/2006/main"/>
           <a:p xmlns:a="http://schemas.openxmlformats.org/drawingml/2006/main">
             <a:pPr algn="l">
+              <a:buNone/>
               <a:defRPr sz="1350" b="1">
                 <a:solidFill>
                   <a:srgbClr val="9A7100"/>
@@ -5160,6 +5607,7 @@
           <a:lstStyle xmlns:a="http://schemas.openxmlformats.org/drawingml/2006/main"/>
           <a:p xmlns:a="http://schemas.openxmlformats.org/drawingml/2006/main">
             <a:pPr algn="l">
+              <a:buNone/>
               <a:defRPr sz="3000" b="1">
                 <a:solidFill>
                   <a:srgbClr val="111827"/>
@@ -5218,6 +5666,7 @@
           <a:lstStyle xmlns:a="http://schemas.openxmlformats.org/drawingml/2006/main"/>
           <a:p xmlns:a="http://schemas.openxmlformats.org/drawingml/2006/main">
             <a:pPr algn="l">
+              <a:buNone/>
               <a:defRPr sz="1800" b="1">
                 <a:solidFill>
                   <a:srgbClr val="111827"/>
@@ -5276,6 +5725,7 @@
           <a:lstStyle xmlns:a="http://schemas.openxmlformats.org/drawingml/2006/main"/>
           <a:p xmlns:a="http://schemas.openxmlformats.org/drawingml/2006/main">
             <a:pPr algn="l">
+              <a:buNone/>
               <a:defRPr sz="1500" b="0">
                 <a:solidFill>
                   <a:srgbClr val="667085"/>
@@ -5299,6 +5749,7 @@
           </a:p>
           <a:p xmlns:a="http://schemas.openxmlformats.org/drawingml/2006/main">
             <a:pPr algn="l">
+              <a:buNone/>
               <a:defRPr sz="1500" b="0">
                 <a:solidFill>
                   <a:srgbClr val="667085"/>
@@ -5357,6 +5808,7 @@
           <a:lstStyle xmlns:a="http://schemas.openxmlformats.org/drawingml/2006/main"/>
           <a:p xmlns:a="http://schemas.openxmlformats.org/drawingml/2006/main">
             <a:pPr algn="l">
+              <a:buNone/>
               <a:defRPr sz="1350" b="1">
                 <a:solidFill>
                   <a:srgbClr val="8A6400"/>
@@ -5415,6 +5867,7 @@
           <a:lstStyle xmlns:a="http://schemas.openxmlformats.org/drawingml/2006/main"/>
           <a:p xmlns:a="http://schemas.openxmlformats.org/drawingml/2006/main">
             <a:pPr algn="l">
+              <a:buNone/>
               <a:defRPr sz="1350" b="1">
                 <a:solidFill>
                   <a:srgbClr val="3D8DFF"/>
@@ -5473,6 +5926,7 @@
           <a:lstStyle xmlns:a="http://schemas.openxmlformats.org/drawingml/2006/main"/>
           <a:p xmlns:a="http://schemas.openxmlformats.org/drawingml/2006/main">
             <a:pPr algn="l">
+              <a:buNone/>
               <a:defRPr sz="3000" b="1">
                 <a:solidFill>
                   <a:srgbClr val="111827"/>
@@ -5531,6 +5985,7 @@
           <a:lstStyle xmlns:a="http://schemas.openxmlformats.org/drawingml/2006/main"/>
           <a:p xmlns:a="http://schemas.openxmlformats.org/drawingml/2006/main">
             <a:pPr algn="l">
+              <a:buNone/>
               <a:defRPr sz="1800" b="1">
                 <a:solidFill>
                   <a:srgbClr val="111827"/>
@@ -5589,6 +6044,7 @@
           <a:lstStyle xmlns:a="http://schemas.openxmlformats.org/drawingml/2006/main"/>
           <a:p xmlns:a="http://schemas.openxmlformats.org/drawingml/2006/main">
             <a:pPr algn="l">
+              <a:buNone/>
               <a:defRPr sz="1500" b="0">
                 <a:solidFill>
                   <a:srgbClr val="667085"/>
@@ -5612,6 +6068,7 @@
           </a:p>
           <a:p xmlns:a="http://schemas.openxmlformats.org/drawingml/2006/main">
             <a:pPr algn="l">
+              <a:buNone/>
               <a:defRPr sz="1500" b="0">
                 <a:solidFill>
                   <a:srgbClr val="667085"/>
@@ -5670,6 +6127,7 @@
           <a:lstStyle xmlns:a="http://schemas.openxmlformats.org/drawingml/2006/main"/>
           <a:p xmlns:a="http://schemas.openxmlformats.org/drawingml/2006/main">
             <a:pPr algn="l">
+              <a:buNone/>
               <a:defRPr sz="1350" b="1">
                 <a:solidFill>
                   <a:srgbClr val="087F5B"/>
@@ -5728,6 +6186,7 @@
           <a:lstStyle xmlns:a="http://schemas.openxmlformats.org/drawingml/2006/main"/>
           <a:p xmlns:a="http://schemas.openxmlformats.org/drawingml/2006/main">
             <a:pPr algn="l">
+              <a:buNone/>
               <a:defRPr sz="900" b="0">
                 <a:solidFill>
                   <a:srgbClr val="667085"/>
@@ -5815,6 +6274,7 @@
           <a:lstStyle xmlns:a="http://schemas.openxmlformats.org/drawingml/2006/main"/>
           <a:p xmlns:a="http://schemas.openxmlformats.org/drawingml/2006/main">
             <a:pPr algn="l">
+              <a:buNone/>
               <a:defRPr sz="1200" b="1">
                 <a:solidFill>
                   <a:srgbClr val="667085"/>
@@ -5873,6 +6333,7 @@
           <a:lstStyle xmlns:a="http://schemas.openxmlformats.org/drawingml/2006/main"/>
           <a:p xmlns:a="http://schemas.openxmlformats.org/drawingml/2006/main">
             <a:pPr algn="l">
+              <a:buNone/>
               <a:defRPr sz="3300" b="1">
                 <a:solidFill>
                   <a:srgbClr val="111827"/>
@@ -5962,6 +6423,7 @@
           <a:lstStyle xmlns:a="http://schemas.openxmlformats.org/drawingml/2006/main"/>
           <a:p xmlns:a="http://schemas.openxmlformats.org/drawingml/2006/main">
             <a:pPr algn="r">
+              <a:buNone/>
               <a:defRPr sz="1050" b="0">
                 <a:solidFill>
                   <a:srgbClr val="667085"/>
@@ -6020,6 +6482,7 @@
           <a:lstStyle xmlns:a="http://schemas.openxmlformats.org/drawingml/2006/main"/>
           <a:p xmlns:a="http://schemas.openxmlformats.org/drawingml/2006/main">
             <a:pPr algn="l">
+              <a:buNone/>
               <a:defRPr sz="4650" b="1">
                 <a:solidFill>
                   <a:srgbClr val="D92D20"/>
@@ -6078,6 +6541,7 @@
           <a:lstStyle xmlns:a="http://schemas.openxmlformats.org/drawingml/2006/main"/>
           <a:p xmlns:a="http://schemas.openxmlformats.org/drawingml/2006/main">
             <a:pPr algn="l">
+              <a:buNone/>
               <a:defRPr sz="1500" b="0">
                 <a:solidFill>
                   <a:srgbClr val="667085"/>
@@ -6136,6 +6600,7 @@
           <a:lstStyle xmlns:a="http://schemas.openxmlformats.org/drawingml/2006/main"/>
           <a:p xmlns:a="http://schemas.openxmlformats.org/drawingml/2006/main">
             <a:pPr algn="l">
+              <a:buNone/>
               <a:defRPr sz="3600" b="1">
                 <a:solidFill>
                   <a:srgbClr val="111827"/>
@@ -6194,6 +6659,7 @@
           <a:lstStyle xmlns:a="http://schemas.openxmlformats.org/drawingml/2006/main"/>
           <a:p xmlns:a="http://schemas.openxmlformats.org/drawingml/2006/main">
             <a:pPr algn="l">
+              <a:buNone/>
               <a:defRPr sz="1350" b="0">
                 <a:solidFill>
                   <a:srgbClr val="667085"/>
@@ -6252,6 +6718,7 @@
           <a:lstStyle xmlns:a="http://schemas.openxmlformats.org/drawingml/2006/main"/>
           <a:p xmlns:a="http://schemas.openxmlformats.org/drawingml/2006/main">
             <a:pPr algn="l">
+              <a:buNone/>
               <a:defRPr sz="3600" b="1">
                 <a:solidFill>
                   <a:srgbClr val="111827"/>
@@ -6310,6 +6777,7 @@
           <a:lstStyle xmlns:a="http://schemas.openxmlformats.org/drawingml/2006/main"/>
           <a:p xmlns:a="http://schemas.openxmlformats.org/drawingml/2006/main">
             <a:pPr algn="l">
+              <a:buNone/>
               <a:defRPr sz="1350" b="0">
                 <a:solidFill>
                   <a:srgbClr val="667085"/>
@@ -6368,6 +6836,7 @@
           <a:lstStyle xmlns:a="http://schemas.openxmlformats.org/drawingml/2006/main"/>
           <a:p xmlns:a="http://schemas.openxmlformats.org/drawingml/2006/main">
             <a:pPr algn="l">
+              <a:buNone/>
               <a:defRPr sz="3600" b="1">
                 <a:solidFill>
                   <a:srgbClr val="111827"/>
@@ -6426,6 +6895,7 @@
           <a:lstStyle xmlns:a="http://schemas.openxmlformats.org/drawingml/2006/main"/>
           <a:p xmlns:a="http://schemas.openxmlformats.org/drawingml/2006/main">
             <a:pPr algn="l">
+              <a:buNone/>
               <a:defRPr sz="1350" b="0">
                 <a:solidFill>
                   <a:srgbClr val="667085"/>
@@ -6515,6 +6985,7 @@
           <a:lstStyle xmlns:a="http://schemas.openxmlformats.org/drawingml/2006/main"/>
           <a:p xmlns:a="http://schemas.openxmlformats.org/drawingml/2006/main">
             <a:pPr algn="l">
+              <a:buNone/>
               <a:defRPr sz="1500" b="1">
                 <a:solidFill>
                   <a:srgbClr val="8A6400"/>
@@ -6573,6 +7044,7 @@
           <a:lstStyle xmlns:a="http://schemas.openxmlformats.org/drawingml/2006/main"/>
           <a:p xmlns:a="http://schemas.openxmlformats.org/drawingml/2006/main">
             <a:pPr algn="l">
+              <a:buNone/>
               <a:defRPr sz="3150" b="1">
                 <a:solidFill>
                   <a:srgbClr val="111827"/>
@@ -6631,6 +7103,7 @@
           <a:lstStyle xmlns:a="http://schemas.openxmlformats.org/drawingml/2006/main"/>
           <a:p xmlns:a="http://schemas.openxmlformats.org/drawingml/2006/main">
             <a:pPr algn="l">
+              <a:buNone/>
               <a:defRPr sz="1725" b="0">
                 <a:solidFill>
                   <a:srgbClr val="111827"/>
@@ -6654,6 +7127,7 @@
           </a:p>
           <a:p xmlns:a="http://schemas.openxmlformats.org/drawingml/2006/main">
             <a:pPr algn="l">
+              <a:buNone/>
               <a:defRPr sz="1725" b="0">
                 <a:solidFill>
                   <a:srgbClr val="111827"/>
@@ -6712,6 +7186,7 @@
           <a:lstStyle xmlns:a="http://schemas.openxmlformats.org/drawingml/2006/main"/>
           <a:p xmlns:a="http://schemas.openxmlformats.org/drawingml/2006/main">
             <a:pPr algn="l">
+              <a:buNone/>
               <a:defRPr sz="1425" b="1">
                 <a:solidFill>
                   <a:srgbClr val="087F5B"/>
@@ -6770,6 +7245,7 @@
           <a:lstStyle xmlns:a="http://schemas.openxmlformats.org/drawingml/2006/main"/>
           <a:p xmlns:a="http://schemas.openxmlformats.org/drawingml/2006/main">
             <a:pPr algn="l">
+              <a:buNone/>
               <a:defRPr sz="900" b="0">
                 <a:solidFill>
                   <a:srgbClr val="667085"/>
@@ -6857,6 +7333,7 @@
           <a:lstStyle xmlns:a="http://schemas.openxmlformats.org/drawingml/2006/main"/>
           <a:p xmlns:a="http://schemas.openxmlformats.org/drawingml/2006/main">
             <a:pPr algn="l">
+              <a:buNone/>
               <a:defRPr sz="1200" b="1">
                 <a:solidFill>
                   <a:srgbClr val="667085"/>
@@ -6915,6 +7392,7 @@
           <a:lstStyle xmlns:a="http://schemas.openxmlformats.org/drawingml/2006/main"/>
           <a:p xmlns:a="http://schemas.openxmlformats.org/drawingml/2006/main">
             <a:pPr algn="l">
+              <a:buNone/>
               <a:defRPr sz="3300" b="1">
                 <a:solidFill>
                   <a:srgbClr val="111827"/>
@@ -7004,6 +7482,7 @@
           <a:lstStyle xmlns:a="http://schemas.openxmlformats.org/drawingml/2006/main"/>
           <a:p xmlns:a="http://schemas.openxmlformats.org/drawingml/2006/main">
             <a:pPr algn="r">
+              <a:buNone/>
               <a:defRPr sz="1050" b="0">
                 <a:solidFill>
                   <a:srgbClr val="667085"/>
@@ -7029,7 +7508,7 @@
       </p:sp>
       <p:graphicFrame>
         <p:nvGraphicFramePr>
-          <p:cNvPr id="17" name="Chart"/>
+          <p:cNvPr id="18" name="Chart"/>
           <p:cNvGraphicFramePr/>
           <p:nvPr/>
         </p:nvGraphicFramePr>
@@ -7039,7 +7518,7 @@
         </p:xfrm>
         <a:graphic xmlns:a="http://schemas.openxmlformats.org/drawingml/2006/main">
           <a:graphicData uri="http://schemas.openxmlformats.org/drawingml/2006/chart">
-            <c:chart xmlns:r="http://schemas.openxmlformats.org/officeDocument/2006/relationships" xmlns:c="http://schemas.openxmlformats.org/drawingml/2006/chart" r:id="R59d4bc48cee644e0"/>
+            <c:chart xmlns:r="http://schemas.openxmlformats.org/officeDocument/2006/relationships" xmlns:c="http://schemas.openxmlformats.org/drawingml/2006/chart" r:id="R1eceffb77ef34bcd"/>
           </a:graphicData>
         </a:graphic>
       </p:graphicFrame>
@@ -7109,6 +7588,7 @@
           <a:lstStyle xmlns:a="http://schemas.openxmlformats.org/drawingml/2006/main"/>
           <a:p xmlns:a="http://schemas.openxmlformats.org/drawingml/2006/main">
             <a:pPr algn="l">
+              <a:buNone/>
               <a:defRPr sz="4050" b="1">
                 <a:solidFill>
                   <a:srgbClr val="111827"/>
@@ -7167,6 +7647,7 @@
           <a:lstStyle xmlns:a="http://schemas.openxmlformats.org/drawingml/2006/main"/>
           <a:p xmlns:a="http://schemas.openxmlformats.org/drawingml/2006/main">
             <a:pPr algn="l">
+              <a:buNone/>
               <a:defRPr sz="1425" b="0">
                 <a:solidFill>
                   <a:srgbClr val="667085"/>
@@ -7225,6 +7706,7 @@
           <a:lstStyle xmlns:a="http://schemas.openxmlformats.org/drawingml/2006/main"/>
           <a:p xmlns:a="http://schemas.openxmlformats.org/drawingml/2006/main">
             <a:pPr algn="l">
+              <a:buNone/>
               <a:defRPr sz="3300" b="1">
                 <a:solidFill>
                   <a:srgbClr val="087F5B"/>
@@ -7283,6 +7765,7 @@
           <a:lstStyle xmlns:a="http://schemas.openxmlformats.org/drawingml/2006/main"/>
           <a:p xmlns:a="http://schemas.openxmlformats.org/drawingml/2006/main">
             <a:pPr algn="l">
+              <a:buNone/>
               <a:defRPr sz="1350" b="0">
                 <a:solidFill>
                   <a:srgbClr val="667085"/>
@@ -7341,6 +7824,7 @@
           <a:lstStyle xmlns:a="http://schemas.openxmlformats.org/drawingml/2006/main"/>
           <a:p xmlns:a="http://schemas.openxmlformats.org/drawingml/2006/main">
             <a:pPr algn="l">
+              <a:buNone/>
               <a:defRPr sz="1425" b="1">
                 <a:solidFill>
                   <a:srgbClr val="D92D20"/>
@@ -7399,6 +7883,7 @@
           <a:lstStyle xmlns:a="http://schemas.openxmlformats.org/drawingml/2006/main"/>
           <a:p xmlns:a="http://schemas.openxmlformats.org/drawingml/2006/main">
             <a:pPr algn="l">
+              <a:buNone/>
               <a:defRPr sz="900" b="0">
                 <a:solidFill>
                   <a:srgbClr val="667085"/>
@@ -7486,6 +7971,7 @@
           <a:lstStyle xmlns:a="http://schemas.openxmlformats.org/drawingml/2006/main"/>
           <a:p xmlns:a="http://schemas.openxmlformats.org/drawingml/2006/main">
             <a:pPr algn="l">
+              <a:buNone/>
               <a:defRPr sz="1200" b="1">
                 <a:solidFill>
                   <a:srgbClr val="667085"/>
@@ -7544,6 +8030,7 @@
           <a:lstStyle xmlns:a="http://schemas.openxmlformats.org/drawingml/2006/main"/>
           <a:p xmlns:a="http://schemas.openxmlformats.org/drawingml/2006/main">
             <a:pPr algn="l">
+              <a:buNone/>
               <a:defRPr sz="3300" b="1">
                 <a:solidFill>
                   <a:srgbClr val="111827"/>
@@ -7633,6 +8120,7 @@
           <a:lstStyle xmlns:a="http://schemas.openxmlformats.org/drawingml/2006/main"/>
           <a:p xmlns:a="http://schemas.openxmlformats.org/drawingml/2006/main">
             <a:pPr algn="r">
+              <a:buNone/>
               <a:defRPr sz="1050" b="0">
                 <a:solidFill>
                   <a:srgbClr val="667085"/>
@@ -7691,6 +8179,7 @@
           <a:lstStyle xmlns:a="http://schemas.openxmlformats.org/drawingml/2006/main"/>
           <a:p xmlns:a="http://schemas.openxmlformats.org/drawingml/2006/main">
             <a:pPr algn="ctr">
+              <a:buNone/>
               <a:defRPr sz="1950" b="1">
                 <a:solidFill>
                   <a:srgbClr val="111827"/>
@@ -7749,6 +8238,7 @@
           <a:lstStyle xmlns:a="http://schemas.openxmlformats.org/drawingml/2006/main"/>
           <a:p xmlns:a="http://schemas.openxmlformats.org/drawingml/2006/main">
             <a:pPr algn="ctr">
+              <a:buNone/>
               <a:defRPr sz="1950" b="1">
                 <a:solidFill>
                   <a:srgbClr val="111827"/>
@@ -7838,6 +8328,7 @@
           <a:lstStyle xmlns:a="http://schemas.openxmlformats.org/drawingml/2006/main"/>
           <a:p xmlns:a="http://schemas.openxmlformats.org/drawingml/2006/main">
             <a:pPr algn="l">
+              <a:buNone/>
               <a:defRPr sz="1575" b="1">
                 <a:solidFill>
                   <a:srgbClr val="667085"/>
@@ -7896,6 +8387,7 @@
           <a:lstStyle xmlns:a="http://schemas.openxmlformats.org/drawingml/2006/main"/>
           <a:p xmlns:a="http://schemas.openxmlformats.org/drawingml/2006/main">
             <a:pPr algn="ctr">
+              <a:buNone/>
               <a:defRPr sz="1875" b="1">
                 <a:solidFill>
                   <a:srgbClr val="D92D20"/>
@@ -7954,6 +8446,7 @@
           <a:lstStyle xmlns:a="http://schemas.openxmlformats.org/drawingml/2006/main"/>
           <a:p xmlns:a="http://schemas.openxmlformats.org/drawingml/2006/main">
             <a:pPr algn="ctr">
+              <a:buNone/>
               <a:defRPr sz="1875" b="1">
                 <a:solidFill>
                   <a:srgbClr val="D92D20"/>
@@ -8043,6 +8536,7 @@
           <a:lstStyle xmlns:a="http://schemas.openxmlformats.org/drawingml/2006/main"/>
           <a:p xmlns:a="http://schemas.openxmlformats.org/drawingml/2006/main">
             <a:pPr algn="l">
+              <a:buNone/>
               <a:defRPr sz="1575" b="0">
                 <a:solidFill>
                   <a:srgbClr val="667085"/>
@@ -8101,6 +8595,7 @@
           <a:lstStyle xmlns:a="http://schemas.openxmlformats.org/drawingml/2006/main"/>
           <a:p xmlns:a="http://schemas.openxmlformats.org/drawingml/2006/main">
             <a:pPr algn="ctr">
+              <a:buNone/>
               <a:defRPr sz="1875" b="1">
                 <a:solidFill>
                   <a:srgbClr val="111827"/>
@@ -8159,6 +8654,7 @@
           <a:lstStyle xmlns:a="http://schemas.openxmlformats.org/drawingml/2006/main"/>
           <a:p xmlns:a="http://schemas.openxmlformats.org/drawingml/2006/main">
             <a:pPr algn="ctr">
+              <a:buNone/>
               <a:defRPr sz="1875" b="1">
                 <a:solidFill>
                   <a:srgbClr val="111827"/>
@@ -8248,6 +8744,7 @@
           <a:lstStyle xmlns:a="http://schemas.openxmlformats.org/drawingml/2006/main"/>
           <a:p xmlns:a="http://schemas.openxmlformats.org/drawingml/2006/main">
             <a:pPr algn="l">
+              <a:buNone/>
               <a:defRPr sz="1575" b="0">
                 <a:solidFill>
                   <a:srgbClr val="667085"/>
@@ -8306,6 +8803,7 @@
           <a:lstStyle xmlns:a="http://schemas.openxmlformats.org/drawingml/2006/main"/>
           <a:p xmlns:a="http://schemas.openxmlformats.org/drawingml/2006/main">
             <a:pPr algn="ctr">
+              <a:buNone/>
               <a:defRPr sz="1875" b="1">
                 <a:solidFill>
                   <a:srgbClr val="111827"/>
@@ -8364,6 +8862,7 @@
           <a:lstStyle xmlns:a="http://schemas.openxmlformats.org/drawingml/2006/main"/>
           <a:p xmlns:a="http://schemas.openxmlformats.org/drawingml/2006/main">
             <a:pPr algn="ctr">
+              <a:buNone/>
               <a:defRPr sz="1875" b="1">
                 <a:solidFill>
                   <a:srgbClr val="111827"/>
@@ -8453,6 +8952,7 @@
           <a:lstStyle xmlns:a="http://schemas.openxmlformats.org/drawingml/2006/main"/>
           <a:p xmlns:a="http://schemas.openxmlformats.org/drawingml/2006/main">
             <a:pPr algn="l">
+              <a:buNone/>
               <a:defRPr sz="1575" b="0">
                 <a:solidFill>
                   <a:srgbClr val="667085"/>
@@ -8511,6 +9011,7 @@
           <a:lstStyle xmlns:a="http://schemas.openxmlformats.org/drawingml/2006/main"/>
           <a:p xmlns:a="http://schemas.openxmlformats.org/drawingml/2006/main">
             <a:pPr algn="ctr">
+              <a:buNone/>
               <a:defRPr sz="1875" b="1">
                 <a:solidFill>
                   <a:srgbClr val="111827"/>
@@ -8569,6 +9070,7 @@
           <a:lstStyle xmlns:a="http://schemas.openxmlformats.org/drawingml/2006/main"/>
           <a:p xmlns:a="http://schemas.openxmlformats.org/drawingml/2006/main">
             <a:pPr algn="ctr">
+              <a:buNone/>
               <a:defRPr sz="1875" b="1">
                 <a:solidFill>
                   <a:srgbClr val="111827"/>
@@ -8658,6 +9160,7 @@
           <a:lstStyle xmlns:a="http://schemas.openxmlformats.org/drawingml/2006/main"/>
           <a:p xmlns:a="http://schemas.openxmlformats.org/drawingml/2006/main">
             <a:pPr algn="ctr">
+              <a:buNone/>
               <a:defRPr sz="1500" b="1">
                 <a:solidFill>
                   <a:srgbClr val="111827"/>
@@ -8716,6 +9219,7 @@
           <a:lstStyle xmlns:a="http://schemas.openxmlformats.org/drawingml/2006/main"/>
           <a:p xmlns:a="http://schemas.openxmlformats.org/drawingml/2006/main">
             <a:pPr algn="l">
+              <a:buNone/>
               <a:defRPr sz="900" b="0">
                 <a:solidFill>
                   <a:srgbClr val="667085"/>
@@ -8834,6 +9338,7 @@
           <a:lstStyle xmlns:a="http://schemas.openxmlformats.org/drawingml/2006/main"/>
           <a:p xmlns:a="http://schemas.openxmlformats.org/drawingml/2006/main">
             <a:pPr algn="l">
+              <a:buNone/>
               <a:defRPr sz="1350" b="1">
                 <a:solidFill>
                   <a:srgbClr val="667085"/>
@@ -8892,6 +9397,7 @@
           <a:lstStyle xmlns:a="http://schemas.openxmlformats.org/drawingml/2006/main"/>
           <a:p xmlns:a="http://schemas.openxmlformats.org/drawingml/2006/main">
             <a:pPr algn="l">
+              <a:buNone/>
               <a:defRPr sz="4950" b="1">
                 <a:solidFill>
                   <a:srgbClr val="111827"/>
@@ -8915,6 +9421,7 @@
           </a:p>
           <a:p xmlns:a="http://schemas.openxmlformats.org/drawingml/2006/main">
             <a:pPr algn="l">
+              <a:buNone/>
               <a:defRPr sz="4950" b="1">
                 <a:solidFill>
                   <a:srgbClr val="111827"/>
@@ -8938,6 +9445,7 @@
           </a:p>
           <a:p xmlns:a="http://schemas.openxmlformats.org/drawingml/2006/main">
             <a:pPr algn="l">
+              <a:buNone/>
               <a:defRPr sz="4950" b="1">
                 <a:solidFill>
                   <a:srgbClr val="111827"/>
@@ -8977,8 +9485,8 @@
         </p:nvSpPr>
         <p:spPr>
           <a:xfrm xmlns:a="http://schemas.openxmlformats.org/drawingml/2006/main">
-            <a:off x="533400" y="4400550"/>
-            <a:ext cx="8858250" cy="514350"/>
+            <a:off x="533400" y="4267200"/>
+            <a:ext cx="8858250" cy="838200"/>
           </a:xfrm>
           <a:prstGeom xmlns:a="http://schemas.openxmlformats.org/drawingml/2006/main" prst="rect">
             <a:avLst/>
@@ -8996,6 +9504,7 @@
           <a:lstStyle xmlns:a="http://schemas.openxmlformats.org/drawingml/2006/main"/>
           <a:p xmlns:a="http://schemas.openxmlformats.org/drawingml/2006/main">
             <a:pPr algn="l">
+              <a:buNone/>
               <a:defRPr sz="1800" b="1">
                 <a:solidFill>
                   <a:srgbClr val="111827"/>
@@ -9014,7 +9523,8 @@
                 <a:ea typeface="PingFang SC"/>
                 <a:cs typeface="PingFang SC"/>
               </a:rPr>
-              <a:t>选 SOP  →  导入对话  →  确认检查尺  →  门禁 / 证据 / 归因</a:t>
+              <a:t>上传材料 → 生成标准 → 逐通检查
+统计决策 → 根因归因 → 修复回归</a:t>
             </a:r>
           </a:p>
         </p:txBody>
@@ -9054,6 +9564,7 @@
           <a:lstStyle xmlns:a="http://schemas.openxmlformats.org/drawingml/2006/main"/>
           <a:p xmlns:a="http://schemas.openxmlformats.org/drawingml/2006/main">
             <a:pPr algn="l">
+              <a:buNone/>
               <a:defRPr sz="1650" b="1">
                 <a:solidFill>
                   <a:srgbClr val="087F5B"/>
@@ -9072,7 +9583,7 @@
                 <a:ea typeface="PingFang SC"/>
                 <a:cs typeface="PingFang SC"/>
               </a:rPr>
-              <a:t>下一步：现场实跑 1 通，30 秒内回到原始证据。</a:t>
+              <a:t>现场演示：选一组样例，六步运行后从结论回到原始证据。</a:t>
             </a:r>
           </a:p>
         </p:txBody>
@@ -9112,6 +9623,7 @@
           <a:lstStyle xmlns:a="http://schemas.openxmlformats.org/drawingml/2006/main"/>
           <a:p xmlns:a="http://schemas.openxmlformats.org/drawingml/2006/main">
             <a:pPr algn="ctr">
+              <a:buNone/>
               <a:defRPr sz="4050" b="1">
                 <a:solidFill>
                   <a:srgbClr val="111827"/>
@@ -9170,6 +9682,7 @@
           <a:lstStyle xmlns:a="http://schemas.openxmlformats.org/drawingml/2006/main"/>
           <a:p xmlns:a="http://schemas.openxmlformats.org/drawingml/2006/main">
             <a:pPr algn="r">
+              <a:buNone/>
               <a:defRPr sz="1050" b="0">
                 <a:solidFill>
                   <a:srgbClr val="111827"/>

</xml_diff>